<commit_message>
Update forest-green, midnight-blue, and warm-coral templates
Co-Authored-By: Claude Opus 4.6 (1M context) <noreply@anthropic.com>
</commit_message>
<xml_diff>
--- a/templates/forest-green.pptx
+++ b/templates/forest-green.pptx
@@ -107,6 +107,11 @@
       </a:defRPr>
     </a:lvl9pPr>
   </p:defaultTextStyle>
+  <p:extLst>
+    <p:ext uri="{EFAFB233-063F-42B5-8137-9DF3F51BA10A}">
+      <p15:sldGuideLst xmlns:p15="http://schemas.microsoft.com/office/powerpoint/2012/main"/>
+    </p:ext>
+  </p:extLst>
 </p:presentation>
 </file>
 
@@ -773,14 +778,17 @@
                 <a:solidFill>
                   <a:schemeClr val="dk2"/>
                 </a:solidFill>
+                <a:latin typeface="Georgia" panose="02040502050405020303" pitchFamily="18" charset="0"/>
               </a:defRPr>
             </a:lvl1pPr>
           </a:lstStyle>
           <a:p>
             <a:fld id="{A1B2C3D4-E5F6-7890-ABCD-EF1234567890}" type="datetimeFigureOut">
-              <a:rPr lang="en-US"/>
-              <a:t>1/1/2000</a:t>
+              <a:rPr lang="en-US" smtClean="0"/>
+              <a:pPr/>
+              <a:t>4/4/26</a:t>
             </a:fld>
+            <a:endParaRPr lang="en-US"/>
           </a:p>
         </p:txBody>
       </p:sp>
@@ -811,6 +819,7 @@
                 <a:solidFill>
                   <a:schemeClr val="dk2"/>
                 </a:solidFill>
+                <a:latin typeface="Georgia" panose="02040502050405020303" pitchFamily="18" charset="0"/>
               </a:defRPr>
             </a:lvl1pPr>
           </a:lstStyle>
@@ -846,14 +855,17 @@
                 <a:solidFill>
                   <a:schemeClr val="dk2"/>
                 </a:solidFill>
+                <a:latin typeface="Georgia" panose="02040502050405020303" pitchFamily="18" charset="0"/>
               </a:defRPr>
             </a:lvl1pPr>
           </a:lstStyle>
           <a:p>
             <a:fld id="{B2C3D4E5-F6A7-8901-BCDE-F12345678901}" type="slidenum">
-              <a:rPr lang="en-US"/>
+              <a:rPr lang="en-US" smtClean="0"/>
+              <a:pPr/>
               <a:t>‹#›</a:t>
             </a:fld>
+            <a:endParaRPr lang="en-US"/>
           </a:p>
         </p:txBody>
       </p:sp>
@@ -864,9 +876,9 @@
           <p:nvPr/>
         </p:nvSpPr>
         <p:spPr>
-          <a:xfrm>
-            <a:off x="0" y="0"/>
-            <a:ext cx="228600" cy="6858000"/>
+          <a:xfrm rot="5400000">
+            <a:off x="5977093" y="-5984719"/>
+            <a:ext cx="237813" cy="12192000"/>
           </a:xfrm>
           <a:prstGeom prst="rect">
             <a:avLst/>
@@ -882,7 +894,9 @@
           <a:bodyPr/>
           <a:lstStyle/>
           <a:p>
-            <a:endParaRPr lang="en-US"/>
+            <a:endParaRPr lang="en-US">
+              <a:latin typeface="Georgia" panose="02040502050405020303" pitchFamily="18" charset="0"/>
+            </a:endParaRPr>
           </a:p>
         </p:txBody>
       </p:sp>
@@ -911,7 +925,7 @@
           <a:solidFill>
             <a:schemeClr val="dk2"/>
           </a:solidFill>
-          <a:latin typeface="+mj-lt"/>
+          <a:latin typeface="Georgia" panose="02040502050405020303" pitchFamily="18" charset="0"/>
           <a:ea typeface="+mj-ea"/>
           <a:cs typeface="+mj-cs"/>
         </a:defRPr>
@@ -933,7 +947,7 @@
           <a:solidFill>
             <a:schemeClr val="dk2"/>
           </a:solidFill>
-          <a:latin typeface="+mn-lt"/>
+          <a:latin typeface="Georgia" panose="02040502050405020303" pitchFamily="18" charset="0"/>
           <a:ea typeface="+mn-ea"/>
           <a:cs typeface="+mn-cs"/>
         </a:defRPr>
@@ -953,7 +967,7 @@
           <a:solidFill>
             <a:schemeClr val="dk2"/>
           </a:solidFill>
-          <a:latin typeface="+mn-lt"/>
+          <a:latin typeface="Georgia" panose="02040502050405020303" pitchFamily="18" charset="0"/>
           <a:ea typeface="+mn-ea"/>
           <a:cs typeface="+mn-cs"/>
         </a:defRPr>
@@ -973,7 +987,7 @@
           <a:solidFill>
             <a:schemeClr val="dk2"/>
           </a:solidFill>
-          <a:latin typeface="+mn-lt"/>
+          <a:latin typeface="Georgia" panose="02040502050405020303" pitchFamily="18" charset="0"/>
           <a:ea typeface="+mn-ea"/>
           <a:cs typeface="+mn-cs"/>
         </a:defRPr>
@@ -993,7 +1007,7 @@
           <a:solidFill>
             <a:schemeClr val="dk2"/>
           </a:solidFill>
-          <a:latin typeface="+mn-lt"/>
+          <a:latin typeface="Georgia" panose="02040502050405020303" pitchFamily="18" charset="0"/>
           <a:ea typeface="+mn-ea"/>
           <a:cs typeface="+mn-cs"/>
         </a:defRPr>
@@ -1013,7 +1027,7 @@
           <a:solidFill>
             <a:schemeClr val="dk2"/>
           </a:solidFill>
-          <a:latin typeface="+mn-lt"/>
+          <a:latin typeface="Georgia" panose="02040502050405020303" pitchFamily="18" charset="0"/>
           <a:ea typeface="+mn-ea"/>
           <a:cs typeface="+mn-cs"/>
         </a:defRPr>

</xml_diff>

<commit_message>
[go-slide-creator-bh5y] Add pwc-template and native blank-title layout to all templates
Add pwc-template (Georgia/Arial, orange accents) as a 5th bundled template
via mktemplate. Add native "Blank + Title" layout (slideLayout7) to all
mktemplate-generated templates so agents get branded layouts without
runtime synthesis. The synthesis code already emits layout_synthesized
fit findings when it fires on non-mktemplate templates.

Co-Authored-By: Claude Opus 4.6 <noreply@anthropic.com>
</commit_message>
<xml_diff>
--- a/templates/forest-green.pptx
+++ b/templates/forest-green.pptx
@@ -107,11 +107,6 @@
       </a:defRPr>
     </a:lvl9pPr>
   </p:defaultTextStyle>
-  <p:extLst>
-    <p:ext uri="{EFAFB233-063F-42B5-8137-9DF3F51BA10A}">
-      <p15:sldGuideLst xmlns:p15="http://schemas.microsoft.com/office/powerpoint/2012/main"/>
-    </p:ext>
-  </p:extLst>
 </p:presentation>
 </file>
 
@@ -633,6 +628,53 @@
 </p:sldLayout>
 </file>
 
+<file path=ppt/slideLayouts/slideLayout7.xml><?xml version="1.0" encoding="utf-8"?>
+<p:sldLayout xmlns:a="http://schemas.openxmlformats.org/drawingml/2006/main" xmlns:r="http://schemas.openxmlformats.org/officeDocument/2006/relationships" xmlns:p="http://schemas.openxmlformats.org/presentationml/2006/main" preserve="1" userDrawn="1">
+  <p:cSld name="Blank + Title">
+    <p:spTree>
+      <p:nvGrpSpPr>
+        <p:cNvPr id="1" name=""/>
+        <p:cNvGrpSpPr/>
+        <p:nvPr/>
+      </p:nvGrpSpPr>
+      <p:grpSpPr>
+        <a:xfrm>
+          <a:off x="0" y="0"/>
+          <a:ext cx="0" cy="0"/>
+          <a:chOff x="0" y="0"/>
+          <a:chExt cx="0" cy="0"/>
+        </a:xfrm>
+      </p:grpSpPr>
+      <p:sp>
+        <p:nvSpPr>
+          <p:cNvPr id="2" name="title"/>
+          <p:cNvSpPr>
+            <a:spLocks noGrp="1"/>
+          </p:cNvSpPr>
+          <p:nvPr>
+            <p:ph type="title"/>
+          </p:nvPr>
+        </p:nvSpPr>
+        <p:spPr/>
+        <p:txBody>
+          <a:bodyPr/>
+          <a:lstStyle/>
+          <a:p>
+            <a:r>
+              <a:rPr lang="en-US"/>
+              <a:t>Click to edit Master title style</a:t>
+            </a:r>
+          </a:p>
+        </p:txBody>
+      </p:sp>
+    </p:spTree>
+  </p:cSld>
+  <p:clrMapOvr>
+    <a:masterClrMapping/>
+  </p:clrMapOvr>
+</p:sldLayout>
+</file>
+
 <file path=ppt/slideMasters/slideMaster1.xml><?xml version="1.0" encoding="utf-8"?>
 <p:sldMaster xmlns:a="http://schemas.openxmlformats.org/drawingml/2006/main" xmlns:r="http://schemas.openxmlformats.org/officeDocument/2006/relationships" xmlns:p="http://schemas.openxmlformats.org/presentationml/2006/main">
   <p:cSld>
@@ -778,17 +820,14 @@
                 <a:solidFill>
                   <a:schemeClr val="dk2"/>
                 </a:solidFill>
-                <a:latin typeface="Georgia" panose="02040502050405020303" pitchFamily="18" charset="0"/>
               </a:defRPr>
             </a:lvl1pPr>
           </a:lstStyle>
           <a:p>
             <a:fld id="{A1B2C3D4-E5F6-7890-ABCD-EF1234567890}" type="datetimeFigureOut">
-              <a:rPr lang="en-US" smtClean="0"/>
-              <a:pPr/>
-              <a:t>4/4/26</a:t>
+              <a:rPr lang="en-US"/>
+              <a:t>1/1/2000</a:t>
             </a:fld>
-            <a:endParaRPr lang="en-US"/>
           </a:p>
         </p:txBody>
       </p:sp>
@@ -819,7 +858,6 @@
                 <a:solidFill>
                   <a:schemeClr val="dk2"/>
                 </a:solidFill>
-                <a:latin typeface="Georgia" panose="02040502050405020303" pitchFamily="18" charset="0"/>
               </a:defRPr>
             </a:lvl1pPr>
           </a:lstStyle>
@@ -855,17 +893,14 @@
                 <a:solidFill>
                   <a:schemeClr val="dk2"/>
                 </a:solidFill>
-                <a:latin typeface="Georgia" panose="02040502050405020303" pitchFamily="18" charset="0"/>
               </a:defRPr>
             </a:lvl1pPr>
           </a:lstStyle>
           <a:p>
             <a:fld id="{B2C3D4E5-F6A7-8901-BCDE-F12345678901}" type="slidenum">
-              <a:rPr lang="en-US" smtClean="0"/>
-              <a:pPr/>
+              <a:rPr lang="en-US"/>
               <a:t>‹#›</a:t>
             </a:fld>
-            <a:endParaRPr lang="en-US"/>
           </a:p>
         </p:txBody>
       </p:sp>
@@ -876,9 +911,9 @@
           <p:nvPr/>
         </p:nvSpPr>
         <p:spPr>
-          <a:xfrm rot="5400000">
-            <a:off x="5977093" y="-5984719"/>
-            <a:ext cx="237813" cy="12192000"/>
+          <a:xfrm>
+            <a:off x="0" y="0"/>
+            <a:ext cx="228600" cy="6858000"/>
           </a:xfrm>
           <a:prstGeom prst="rect">
             <a:avLst/>
@@ -894,9 +929,7 @@
           <a:bodyPr/>
           <a:lstStyle/>
           <a:p>
-            <a:endParaRPr lang="en-US">
-              <a:latin typeface="Georgia" panose="02040502050405020303" pitchFamily="18" charset="0"/>
-            </a:endParaRPr>
+            <a:endParaRPr lang="en-US"/>
           </a:p>
         </p:txBody>
       </p:sp>
@@ -910,6 +943,7 @@
     <p:sldLayoutId id="2147483652" r:id="rId4"/>
     <p:sldLayoutId id="2147483653" r:id="rId5"/>
     <p:sldLayoutId id="2147483654" r:id="rId6"/>
+    <p:sldLayoutId id="2147483655" r:id="rId7"/>
   </p:sldLayoutIdLst>
   <p:txStyles>
     <p:titleStyle>
@@ -925,7 +959,7 @@
           <a:solidFill>
             <a:schemeClr val="dk2"/>
           </a:solidFill>
-          <a:latin typeface="Georgia" panose="02040502050405020303" pitchFamily="18" charset="0"/>
+          <a:latin typeface="+mj-lt"/>
           <a:ea typeface="+mj-ea"/>
           <a:cs typeface="+mj-cs"/>
         </a:defRPr>
@@ -947,7 +981,7 @@
           <a:solidFill>
             <a:schemeClr val="dk2"/>
           </a:solidFill>
-          <a:latin typeface="Georgia" panose="02040502050405020303" pitchFamily="18" charset="0"/>
+          <a:latin typeface="+mn-lt"/>
           <a:ea typeface="+mn-ea"/>
           <a:cs typeface="+mn-cs"/>
         </a:defRPr>
@@ -967,7 +1001,7 @@
           <a:solidFill>
             <a:schemeClr val="dk2"/>
           </a:solidFill>
-          <a:latin typeface="Georgia" panose="02040502050405020303" pitchFamily="18" charset="0"/>
+          <a:latin typeface="+mn-lt"/>
           <a:ea typeface="+mn-ea"/>
           <a:cs typeface="+mn-cs"/>
         </a:defRPr>
@@ -987,7 +1021,7 @@
           <a:solidFill>
             <a:schemeClr val="dk2"/>
           </a:solidFill>
-          <a:latin typeface="Georgia" panose="02040502050405020303" pitchFamily="18" charset="0"/>
+          <a:latin typeface="+mn-lt"/>
           <a:ea typeface="+mn-ea"/>
           <a:cs typeface="+mn-cs"/>
         </a:defRPr>
@@ -1007,7 +1041,7 @@
           <a:solidFill>
             <a:schemeClr val="dk2"/>
           </a:solidFill>
-          <a:latin typeface="Georgia" panose="02040502050405020303" pitchFamily="18" charset="0"/>
+          <a:latin typeface="+mn-lt"/>
           <a:ea typeface="+mn-ea"/>
           <a:cs typeface="+mn-cs"/>
         </a:defRPr>
@@ -1027,7 +1061,7 @@
           <a:solidFill>
             <a:schemeClr val="dk2"/>
           </a:solidFill>
-          <a:latin typeface="Georgia" panose="02040502050405020303" pitchFamily="18" charset="0"/>
+          <a:latin typeface="+mn-lt"/>
           <a:ea typeface="+mn-ea"/>
           <a:cs typeface="+mn-cs"/>
         </a:defRPr>

</xml_diff>

<commit_message>
[go-slide-creator-4bxi] mktemplate(forest-green): title underline + corner brand mark
Replace inline master accent bar with a theme-aware chromeShapes() so each
theme can ship its own slide-master decoration. Forest Green now emits
Option A per the ticket:

* 2pt accent1 (#2E7D32) horizontal underline spanning the title content
  width, 1pt below the master title placeholder.
* 24pt accent3 (#1565C0) right-angled triangle (flipH'd rtTriangle) in
  the bottom-right corner as a quiet brand mark.

Title Slide and Closing layouts opt out via showMasterSp="0", driven by
the new templateDef.HideChromeOnTitle flag, so cover/closer stay clean.
midnight-blue and warm-coral keep the legacy left-edge accent bar and
regenerate byte-identically.

Regenerated templates/forest-green.pptx (template-check PASS, zero
WARN/FAIL) and dropped its now-stale entry from
internal/template/testdata/conformance_allowlist.json.
</commit_message>
<xml_diff>
--- a/templates/forest-green.pptx
+++ b/templates/forest-green.pptx
@@ -111,7 +111,7 @@
 </file>
 
 <file path=ppt/slideLayouts/slideLayout1.xml><?xml version="1.0" encoding="utf-8"?>
-<p:sldLayout xmlns:a="http://schemas.openxmlformats.org/drawingml/2006/main" xmlns:r="http://schemas.openxmlformats.org/officeDocument/2006/relationships" xmlns:p="http://schemas.openxmlformats.org/presentationml/2006/main" type="title" preserve="1">
+<p:sldLayout xmlns:a="http://schemas.openxmlformats.org/drawingml/2006/main" xmlns:r="http://schemas.openxmlformats.org/officeDocument/2006/relationships" xmlns:p="http://schemas.openxmlformats.org/presentationml/2006/main" showMasterSp="0" type="title" preserve="1">
   <p:cSld name="Title Slide">
     <p:spTree>
       <p:nvGrpSpPr>
@@ -474,7 +474,7 @@
       </p:sp>
       <p:sp>
         <p:nvSpPr>
-          <p:cNvPr id="3" name="body"/>
+          <p:cNvPr id="3" name="Section Number"/>
           <p:cNvSpPr>
             <a:spLocks noGrp="1"/>
           </p:cNvSpPr>
@@ -491,9 +491,13 @@
         <p:txBody>
           <a:bodyPr/>
           <a:lstStyle>
-            <a:lvl1pPr marL="11113" indent="-11113">
+            <a:lvl1pPr marL="11113" indent="-11113" algn="r">
               <a:buNone/>
-              <a:defRPr sz="9600"/>
+              <a:defRPr sz="13600">
+                <a:solidFill>
+                  <a:schemeClr val="accent1"/>
+                </a:solidFill>
+              </a:defRPr>
             </a:lvl1pPr>
           </a:lstStyle>
           <a:p>
@@ -514,7 +518,7 @@
 </file>
 
 <file path=ppt/slideLayouts/slideLayout5.xml><?xml version="1.0" encoding="utf-8"?>
-<p:sldLayout xmlns:a="http://schemas.openxmlformats.org/drawingml/2006/main" xmlns:r="http://schemas.openxmlformats.org/officeDocument/2006/relationships" xmlns:p="http://schemas.openxmlformats.org/presentationml/2006/main" preserve="1" userDrawn="1">
+<p:sldLayout xmlns:a="http://schemas.openxmlformats.org/drawingml/2006/main" xmlns:r="http://schemas.openxmlformats.org/officeDocument/2006/relationships" xmlns:p="http://schemas.openxmlformats.org/presentationml/2006/main" showMasterSp="0" preserve="1" userDrawn="1">
   <p:cSld name="Closing">
     <p:spTree>
       <p:nvGrpSpPr>
@@ -906,20 +910,49 @@
       </p:sp>
       <p:sp>
         <p:nvSpPr>
-          <p:cNvPr id="7" name="Accent Bar"/>
+          <p:cNvPr id="7" name="Title Underline"/>
           <p:cNvSpPr/>
           <p:nvPr/>
         </p:nvSpPr>
         <p:spPr>
           <a:xfrm>
-            <a:off x="0" y="0"/>
-            <a:ext cx="228600" cy="6858000"/>
+            <a:off x="838200" y="1703388"/>
+            <a:ext cx="10515600" cy="25400"/>
           </a:xfrm>
           <a:prstGeom prst="rect">
             <a:avLst/>
           </a:prstGeom>
           <a:solidFill>
             <a:schemeClr val="accent1"/>
+          </a:solidFill>
+          <a:ln>
+            <a:noFill/>
+          </a:ln>
+        </p:spPr>
+        <p:txBody>
+          <a:bodyPr/>
+          <a:lstStyle/>
+          <a:p>
+            <a:endParaRPr lang="en-US"/>
+          </a:p>
+        </p:txBody>
+      </p:sp>
+      <p:sp>
+        <p:nvSpPr>
+          <p:cNvPr id="8" name="Corner Mark"/>
+          <p:cNvSpPr/>
+          <p:nvPr/>
+        </p:nvSpPr>
+        <p:spPr>
+          <a:xfrm flipH="1">
+            <a:off x="11887200" y="6553200"/>
+            <a:ext cx="304800" cy="304800"/>
+          </a:xfrm>
+          <a:prstGeom prst="rtTriangle">
+            <a:avLst/>
+          </a:prstGeom>
+          <a:solidFill>
+            <a:schemeClr val="accent3"/>
           </a:solidFill>
           <a:ln>
             <a:noFill/>

</xml_diff>